<commit_message>
updated figures and text of dissertation
</commit_message>
<xml_diff>
--- a/Documentation/Reports and Papers/Dissertation/Figures/10-introduction/components/roadmap.pptx
+++ b/Documentation/Reports and Papers/Dissertation/Figures/10-introduction/components/roadmap.pptx
@@ -7,7 +7,7 @@
   <p:sldIdLst>
     <p:sldId id="256" r:id="rId7"/>
   </p:sldIdLst>
-  <p:sldSz cx="5940000" cy="2484000" type="screen4x3"/>
+  <p:sldSz cx="5943600" cy="3073400" type="screen4x3"/>
   <p:notesSz cx="6858000" cy="9144000"/>
   <p:defaultTextStyle>
     <a:defPPr>
@@ -3088,434 +3088,24 @@
         <p:nvPr/>
       </p:nvGrpSpPr>
       <p:grpSpPr/>
-      <p:sp>
-        <p:nvSpPr>
-          <p:cNvPr id="2" name="Rounded Rectangle 1"/>
-          <p:cNvSpPr/>
-          <p:nvPr/>
-        </p:nvSpPr>
-        <p:spPr>
-          <a:xfrm>
-            <a:off x="108000" y="612000"/>
-            <a:ext cx="1565999" cy="558000"/>
-          </a:xfrm>
-          <a:prstGeom prst="roundRect">
-            <a:avLst>
-              <a:gd name="adj" fmla="val 10000"/>
-            </a:avLst>
-          </a:prstGeom>
-          <a:solidFill>
-            <a:srgbClr val="F2F2F2"/>
-          </a:solidFill>
-          <a:ln w="12700">
-            <a:solidFill>
-              <a:srgbClr val="1F1F1F"/>
-            </a:solidFill>
-          </a:ln>
-        </p:spPr>
-        <p:style>
-          <a:lnRef idx="1">
-            <a:schemeClr val="accent1"/>
-          </a:lnRef>
-          <a:fillRef idx="3">
-            <a:schemeClr val="accent1"/>
-          </a:fillRef>
-          <a:effectRef idx="2">
-            <a:schemeClr val="accent1"/>
-          </a:effectRef>
-          <a:fontRef idx="minor">
-            <a:schemeClr val="lt1"/>
-          </a:fontRef>
-        </p:style>
-        <p:txBody>
-          <a:bodyPr rtlCol="0" anchor="ctr" wrap="square" lIns="43200" rIns="43200" tIns="21600" bIns="21600"/>
-          <a:lstStyle/>
-          <a:p>
-            <a:pPr algn="ctr"/>
-            <a:r>
-              <a:rPr sz="1000" b="1">
-                <a:solidFill>
-                  <a:srgbClr val="1F1F1F"/>
-                </a:solidFill>
-                <a:latin typeface="Arial"/>
-              </a:rPr>
-              <a:t>Human biomechanics</a:t>
-            </a:r>
-          </a:p>
-          <a:p>
-            <a:pPr algn="ctr"/>
-            <a:r>
-              <a:rPr sz="1000">
-                <a:solidFill>
-                  <a:srgbClr val="1F1F1F"/>
-                </a:solidFill>
-                <a:latin typeface="Arial"/>
-              </a:rPr>
-              <a:t>benchmark (Ch. 2)</a:t>
-            </a:r>
-          </a:p>
-        </p:txBody>
-      </p:sp>
-      <p:sp>
-        <p:nvSpPr>
-          <p:cNvPr id="3" name="Rounded Rectangle 2"/>
-          <p:cNvSpPr/>
-          <p:nvPr/>
-        </p:nvSpPr>
-        <p:spPr>
-          <a:xfrm>
-            <a:off x="2196000" y="612000"/>
-            <a:ext cx="1565999" cy="558000"/>
-          </a:xfrm>
-          <a:prstGeom prst="roundRect">
-            <a:avLst>
-              <a:gd name="adj" fmla="val 10000"/>
-            </a:avLst>
-          </a:prstGeom>
-          <a:solidFill>
-            <a:srgbClr val="F2F2F2"/>
-          </a:solidFill>
-          <a:ln w="12700">
-            <a:solidFill>
-              <a:srgbClr val="1F1F1F"/>
-            </a:solidFill>
-          </a:ln>
-        </p:spPr>
-        <p:style>
-          <a:lnRef idx="1">
-            <a:schemeClr val="accent1"/>
-          </a:lnRef>
-          <a:fillRef idx="3">
-            <a:schemeClr val="accent1"/>
-          </a:fillRef>
-          <a:effectRef idx="2">
-            <a:schemeClr val="accent1"/>
-          </a:effectRef>
-          <a:fontRef idx="minor">
-            <a:schemeClr val="lt1"/>
-          </a:fontRef>
-        </p:style>
-        <p:txBody>
-          <a:bodyPr rtlCol="0" anchor="ctr" wrap="square" lIns="43200" rIns="43200" tIns="21600" bIns="21600"/>
-          <a:lstStyle/>
-          <a:p>
-            <a:pPr algn="ctr"/>
-            <a:r>
-              <a:rPr sz="1000" b="1">
-                <a:solidFill>
-                  <a:srgbClr val="1F1F1F"/>
-                </a:solidFill>
-                <a:latin typeface="Arial"/>
-              </a:rPr>
-              <a:t>BPA force models,</a:t>
-            </a:r>
-          </a:p>
-          <a:p>
-            <a:pPr algn="ctr"/>
-            <a:r>
-              <a:rPr sz="1000">
-                <a:solidFill>
-                  <a:srgbClr val="1F1F1F"/>
-                </a:solidFill>
-                <a:latin typeface="Arial"/>
-              </a:rPr>
-              <a:t>validated (Ch. 3)</a:t>
-            </a:r>
-          </a:p>
-        </p:txBody>
-      </p:sp>
-      <p:sp>
-        <p:nvSpPr>
-          <p:cNvPr id="4" name="Rounded Rectangle 3"/>
-          <p:cNvSpPr/>
-          <p:nvPr/>
-        </p:nvSpPr>
-        <p:spPr>
-          <a:xfrm>
-            <a:off x="4284000" y="612000"/>
-            <a:ext cx="1565999" cy="558000"/>
-          </a:xfrm>
-          <a:prstGeom prst="roundRect">
-            <a:avLst>
-              <a:gd name="adj" fmla="val 10000"/>
-            </a:avLst>
-          </a:prstGeom>
-          <a:solidFill>
-            <a:srgbClr val="F2F2F2"/>
-          </a:solidFill>
-          <a:ln w="12700">
-            <a:solidFill>
-              <a:srgbClr val="1F1F1F"/>
-            </a:solidFill>
-          </a:ln>
-        </p:spPr>
-        <p:style>
-          <a:lnRef idx="1">
-            <a:schemeClr val="accent1"/>
-          </a:lnRef>
-          <a:fillRef idx="3">
-            <a:schemeClr val="accent1"/>
-          </a:fillRef>
-          <a:effectRef idx="2">
-            <a:schemeClr val="accent1"/>
-          </a:effectRef>
-          <a:fontRef idx="minor">
-            <a:schemeClr val="lt1"/>
-          </a:fontRef>
-        </p:style>
-        <p:txBody>
-          <a:bodyPr rtlCol="0" anchor="ctr" wrap="square" lIns="43200" rIns="43200" tIns="21600" bIns="21600"/>
-          <a:lstStyle/>
-          <a:p>
-            <a:pPr algn="ctr"/>
-            <a:r>
-              <a:rPr sz="1000" b="1">
-                <a:solidFill>
-                  <a:srgbClr val="1F1F1F"/>
-                </a:solidFill>
-                <a:latin typeface="Arial"/>
-              </a:rPr>
-              <a:t>Torque correction</a:t>
-            </a:r>
-          </a:p>
-          <a:p>
-            <a:pPr algn="ctr"/>
-            <a:r>
-              <a:rPr sz="1000">
-                <a:solidFill>
-                  <a:srgbClr val="1F1F1F"/>
-                </a:solidFill>
-                <a:latin typeface="Arial"/>
-              </a:rPr>
-              <a:t>factors and routes (Ch. 4)</a:t>
-            </a:r>
-          </a:p>
-        </p:txBody>
-      </p:sp>
-      <p:sp>
-        <p:nvSpPr>
-          <p:cNvPr id="5" name="Rounded Rectangle 4"/>
-          <p:cNvSpPr/>
-          <p:nvPr/>
-        </p:nvSpPr>
-        <p:spPr>
-          <a:xfrm>
-            <a:off x="108000" y="1764000"/>
-            <a:ext cx="1565999" cy="558000"/>
-          </a:xfrm>
-          <a:prstGeom prst="roundRect">
-            <a:avLst>
-              <a:gd name="adj" fmla="val 10000"/>
-            </a:avLst>
-          </a:prstGeom>
-          <a:solidFill>
-            <a:srgbClr val="F2F2F2"/>
-          </a:solidFill>
-          <a:ln w="12700">
-            <a:solidFill>
-              <a:srgbClr val="1F1F1F"/>
-            </a:solidFill>
-          </a:ln>
-        </p:spPr>
-        <p:style>
-          <a:lnRef idx="1">
-            <a:schemeClr val="accent1"/>
-          </a:lnRef>
-          <a:fillRef idx="3">
-            <a:schemeClr val="accent1"/>
-          </a:fillRef>
-          <a:effectRef idx="2">
-            <a:schemeClr val="accent1"/>
-          </a:effectRef>
-          <a:fontRef idx="minor">
-            <a:schemeClr val="lt1"/>
-          </a:fontRef>
-        </p:style>
-        <p:txBody>
-          <a:bodyPr rtlCol="0" anchor="ctr" wrap="square" lIns="43200" rIns="43200" tIns="21600" bIns="21600"/>
-          <a:lstStyle/>
-          <a:p>
-            <a:pPr algn="ctr"/>
-            <a:r>
-              <a:rPr sz="1000" b="1">
-                <a:solidFill>
-                  <a:srgbClr val="1F1F1F"/>
-                </a:solidFill>
-                <a:latin typeface="Arial"/>
-              </a:rPr>
-              <a:t>Sensory Afferent</a:t>
-            </a:r>
-          </a:p>
-          <a:p>
-            <a:pPr algn="ctr"/>
-            <a:r>
-              <a:rPr sz="1000">
-                <a:solidFill>
-                  <a:srgbClr val="1F1F1F"/>
-                </a:solidFill>
-                <a:latin typeface="Arial"/>
-              </a:rPr>
-              <a:t>Database (Ch. 5)</a:t>
-            </a:r>
-          </a:p>
-        </p:txBody>
-      </p:sp>
-      <p:sp>
-        <p:nvSpPr>
-          <p:cNvPr id="6" name="Rounded Rectangle 5"/>
-          <p:cNvSpPr/>
-          <p:nvPr/>
-        </p:nvSpPr>
-        <p:spPr>
-          <a:xfrm>
-            <a:off x="2196000" y="1764000"/>
-            <a:ext cx="1565999" cy="558000"/>
-          </a:xfrm>
-          <a:prstGeom prst="roundRect">
-            <a:avLst>
-              <a:gd name="adj" fmla="val 10000"/>
-            </a:avLst>
-          </a:prstGeom>
-          <a:solidFill>
-            <a:srgbClr val="F2F2F2"/>
-          </a:solidFill>
-          <a:ln w="12700">
-            <a:solidFill>
-              <a:srgbClr val="1F1F1F"/>
-            </a:solidFill>
-          </a:ln>
-        </p:spPr>
-        <p:style>
-          <a:lnRef idx="1">
-            <a:schemeClr val="accent1"/>
-          </a:lnRef>
-          <a:fillRef idx="3">
-            <a:schemeClr val="accent1"/>
-          </a:fillRef>
-          <a:effectRef idx="2">
-            <a:schemeClr val="accent1"/>
-          </a:effectRef>
-          <a:fontRef idx="minor">
-            <a:schemeClr val="lt1"/>
-          </a:fontRef>
-        </p:style>
-        <p:txBody>
-          <a:bodyPr rtlCol="0" anchor="ctr" wrap="square" lIns="43200" rIns="43200" tIns="21600" bIns="21600"/>
-          <a:lstStyle/>
-          <a:p>
-            <a:pPr algn="ctr"/>
-            <a:r>
-              <a:rPr sz="1000" b="1">
-                <a:solidFill>
-                  <a:srgbClr val="1F1F1F"/>
-                </a:solidFill>
-                <a:latin typeface="Arial"/>
-              </a:rPr>
-              <a:t>Neuromechanical</a:t>
-            </a:r>
-          </a:p>
-          <a:p>
-            <a:pPr algn="ctr"/>
-            <a:r>
-              <a:rPr sz="1000">
-                <a:solidFill>
-                  <a:srgbClr val="1F1F1F"/>
-                </a:solidFill>
-                <a:latin typeface="Arial"/>
-              </a:rPr>
-              <a:t>simulation tools (Ch. 6)</a:t>
-            </a:r>
-          </a:p>
-        </p:txBody>
-      </p:sp>
-      <p:sp>
-        <p:nvSpPr>
-          <p:cNvPr id="7" name="Rounded Rectangle 6"/>
-          <p:cNvSpPr/>
-          <p:nvPr/>
-        </p:nvSpPr>
-        <p:spPr>
-          <a:xfrm>
-            <a:off x="4284000" y="1764000"/>
-            <a:ext cx="1565999" cy="558000"/>
-          </a:xfrm>
-          <a:prstGeom prst="roundRect">
-            <a:avLst>
-              <a:gd name="adj" fmla="val 10000"/>
-            </a:avLst>
-          </a:prstGeom>
-          <a:solidFill>
-            <a:srgbClr val="F2F2F2"/>
-          </a:solidFill>
-          <a:ln w="12700">
-            <a:solidFill>
-              <a:srgbClr val="1F1F1F"/>
-            </a:solidFill>
-            <a:prstDash val="dash"/>
-          </a:ln>
-        </p:spPr>
-        <p:style>
-          <a:lnRef idx="1">
-            <a:schemeClr val="accent1"/>
-          </a:lnRef>
-          <a:fillRef idx="3">
-            <a:schemeClr val="accent1"/>
-          </a:fillRef>
-          <a:effectRef idx="2">
-            <a:schemeClr val="accent1"/>
-          </a:effectRef>
-          <a:fontRef idx="minor">
-            <a:schemeClr val="lt1"/>
-          </a:fontRef>
-        </p:style>
-        <p:txBody>
-          <a:bodyPr rtlCol="0" anchor="ctr" wrap="square" lIns="43200" rIns="43200" tIns="21600" bIns="21600"/>
-          <a:lstStyle/>
-          <a:p>
-            <a:pPr algn="ctr"/>
-            <a:r>
-              <a:rPr sz="1000" b="1">
-                <a:solidFill>
-                  <a:srgbClr val="1F1F1F"/>
-                </a:solidFill>
-                <a:latin typeface="Arial"/>
-              </a:rPr>
-              <a:t>Physical BPA robot</a:t>
-            </a:r>
-          </a:p>
-          <a:p>
-            <a:pPr algn="ctr"/>
-            <a:r>
-              <a:rPr sz="1000">
-                <a:solidFill>
-                  <a:srgbClr val="1F1F1F"/>
-                </a:solidFill>
-                <a:latin typeface="Arial"/>
-              </a:rPr>
-              <a:t>with SNS control</a:t>
-            </a:r>
-          </a:p>
-        </p:txBody>
-      </p:sp>
       <p:cxnSp>
         <p:nvCxnSpPr>
-          <p:cNvPr id="8" name="Connector 7"/>
+          <p:cNvPr id="2" name="Connector 1"/>
           <p:cNvCxnSpPr/>
           <p:nvPr/>
         </p:nvCxnSpPr>
         <p:spPr>
           <a:xfrm>
-            <a:off x="1673999" y="891000"/>
-            <a:ext cx="504001" cy="0"/>
+            <a:off x="190500" y="152400"/>
+            <a:ext cx="266700" cy="0"/>
           </a:xfrm>
           <a:prstGeom prst="line">
             <a:avLst/>
           </a:prstGeom>
           <a:ln w="12700">
             <a:solidFill>
-              <a:srgbClr val="1F1F1F"/>
+              <a:srgbClr val="243343"/>
             </a:solidFill>
-            <a:tailEnd type="triangle" w="med" len="med"/>
           </a:ln>
         </p:spPr>
         <p:style>
@@ -3535,14 +3125,14 @@
       </p:cxnSp>
       <p:sp>
         <p:nvSpPr>
-          <p:cNvPr id="9" name="TextBox 8"/>
+          <p:cNvPr id="3" name="TextBox 2"/>
           <p:cNvSpPr txBox="1"/>
           <p:nvPr/>
         </p:nvSpPr>
         <p:spPr>
           <a:xfrm>
-            <a:off x="1673999" y="377999"/>
-            <a:ext cx="522000" cy="270000"/>
+            <a:off x="546100" y="63500"/>
+            <a:ext cx="2717800" cy="203200"/>
           </a:xfrm>
           <a:prstGeom prst="rect">
             <a:avLst/>
@@ -3550,43 +3140,53 @@
           <a:noFill/>
         </p:spPr>
         <p:txBody>
-          <a:bodyPr wrap="square" lIns="10800" rIns="10800" tIns="3600" bIns="3600">
-            <a:spAutoFit/>
+          <a:bodyPr wrap="none" lIns="0" rIns="0" tIns="0" bIns="0">
+            <a:noAutofit/>
           </a:bodyPr>
           <a:lstStyle/>
           <a:p>
-            <a:pPr algn="ctr"/>
-            <a:r>
-              <a:rPr sz="1000" b="0">
+            <a:pPr algn="l">
+              <a:lnSpc>
+                <a:spcPts val="1188"/>
+              </a:lnSpc>
+              <a:spcBef>
+                <a:spcPts val="0"/>
+              </a:spcBef>
+              <a:spcAft>
+                <a:spcPts val="0"/>
+              </a:spcAft>
+            </a:pPr>
+            <a:r>
+              <a:rPr sz="1080" b="0" i="0">
                 <a:solidFill>
-                  <a:srgbClr val="1F1F1F"/>
+                  <a:srgbClr val="243343"/>
                 </a:solidFill>
                 <a:latin typeface="Arial"/>
               </a:rPr>
-              <a:t>targets</a:t>
+              <a:t>Developed or used in this dissertation</a:t>
             </a:r>
           </a:p>
         </p:txBody>
       </p:sp>
       <p:cxnSp>
         <p:nvCxnSpPr>
-          <p:cNvPr id="10" name="Connector 9"/>
+          <p:cNvPr id="4" name="Connector 3"/>
           <p:cNvCxnSpPr/>
           <p:nvPr/>
         </p:nvCxnSpPr>
         <p:spPr>
           <a:xfrm>
-            <a:off x="3761999" y="891000"/>
-            <a:ext cx="504001" cy="0"/>
+            <a:off x="3746500" y="152400"/>
+            <a:ext cx="266700" cy="0"/>
           </a:xfrm>
           <a:prstGeom prst="line">
             <a:avLst/>
           </a:prstGeom>
           <a:ln w="12700">
             <a:solidFill>
-              <a:srgbClr val="1F1F1F"/>
+              <a:srgbClr val="243343"/>
             </a:solidFill>
-            <a:tailEnd type="triangle" w="med" len="med"/>
+            <a:prstDash val="dash"/>
           </a:ln>
         </p:spPr>
         <p:style>
@@ -3606,14 +3206,14 @@
       </p:cxnSp>
       <p:sp>
         <p:nvSpPr>
-          <p:cNvPr id="11" name="TextBox 10"/>
+          <p:cNvPr id="5" name="TextBox 4"/>
           <p:cNvSpPr txBox="1"/>
           <p:nvPr/>
         </p:nvSpPr>
         <p:spPr>
           <a:xfrm>
-            <a:off x="3761999" y="377999"/>
-            <a:ext cx="522000" cy="270000"/>
+            <a:off x="4102100" y="63500"/>
+            <a:ext cx="1651000" cy="203200"/>
           </a:xfrm>
           <a:prstGeom prst="rect">
             <a:avLst/>
@@ -3621,196 +3221,996 @@
           <a:noFill/>
         </p:spPr>
         <p:txBody>
-          <a:bodyPr wrap="square" lIns="10800" rIns="10800" tIns="3600" bIns="3600">
-            <a:spAutoFit/>
+          <a:bodyPr wrap="none" lIns="0" rIns="0" tIns="0" bIns="0">
+            <a:noAutofit/>
           </a:bodyPr>
           <a:lstStyle/>
           <a:p>
-            <a:pPr algn="ctr"/>
-            <a:r>
-              <a:rPr sz="1000" b="0">
+            <a:pPr algn="l">
+              <a:lnSpc>
+                <a:spcPts val="1188"/>
+              </a:lnSpc>
+              <a:spcBef>
+                <a:spcPts val="0"/>
+              </a:spcBef>
+              <a:spcAft>
+                <a:spcPts val="0"/>
+              </a:spcAft>
+            </a:pPr>
+            <a:r>
+              <a:rPr sz="1080" b="0" i="0">
                 <a:solidFill>
-                  <a:srgbClr val="1F1F1F"/>
+                  <a:srgbClr val="243343"/>
                 </a:solidFill>
                 <a:latin typeface="Arial"/>
               </a:rPr>
-              <a:t>actuator model</a:t>
+              <a:t>Future integration</a:t>
+            </a:r>
+          </a:p>
+        </p:txBody>
+      </p:sp>
+      <p:sp>
+        <p:nvSpPr>
+          <p:cNvPr id="6" name="Rectangle 5"/>
+          <p:cNvSpPr/>
+          <p:nvPr/>
+        </p:nvSpPr>
+        <p:spPr>
+          <a:xfrm>
+            <a:off x="355600" y="673100"/>
+            <a:ext cx="1422400" cy="647700"/>
+          </a:xfrm>
+          <a:prstGeom prst="rect">
+            <a:avLst/>
+          </a:prstGeom>
+          <a:solidFill>
+            <a:srgbClr val="F1F5F8"/>
+          </a:solidFill>
+          <a:ln w="12700">
+            <a:solidFill>
+              <a:srgbClr val="243343"/>
+            </a:solidFill>
+          </a:ln>
+        </p:spPr>
+        <p:style>
+          <a:lnRef idx="1">
+            <a:schemeClr val="accent1"/>
+          </a:lnRef>
+          <a:fillRef idx="3">
+            <a:schemeClr val="accent1"/>
+          </a:fillRef>
+          <a:effectRef idx="2">
+            <a:schemeClr val="accent1"/>
+          </a:effectRef>
+          <a:fontRef idx="minor">
+            <a:schemeClr val="lt1"/>
+          </a:fontRef>
+        </p:style>
+        <p:txBody>
+          <a:bodyPr rtlCol="0" anchor="ctr"/>
+          <a:lstStyle/>
+          <a:p>
+            <a:pPr algn="ctr"/>
+          </a:p>
+        </p:txBody>
+      </p:sp>
+      <p:sp>
+        <p:nvSpPr>
+          <p:cNvPr id="7" name="TextBox 6"/>
+          <p:cNvSpPr txBox="1"/>
+          <p:nvPr/>
+        </p:nvSpPr>
+        <p:spPr>
+          <a:xfrm>
+            <a:off x="444500" y="745235"/>
+            <a:ext cx="1244600" cy="157734"/>
+          </a:xfrm>
+          <a:prstGeom prst="rect">
+            <a:avLst/>
+          </a:prstGeom>
+          <a:noFill/>
+        </p:spPr>
+        <p:txBody>
+          <a:bodyPr wrap="none" lIns="0" rIns="0" tIns="0" bIns="0">
+            <a:noAutofit/>
+          </a:bodyPr>
+          <a:lstStyle/>
+          <a:p>
+            <a:pPr algn="ctr">
+              <a:lnSpc>
+                <a:spcPts val="1188"/>
+              </a:lnSpc>
+              <a:spcBef>
+                <a:spcPts val="0"/>
+              </a:spcBef>
+              <a:spcAft>
+                <a:spcPts val="0"/>
+              </a:spcAft>
+            </a:pPr>
+            <a:r>
+              <a:rPr sz="1080" b="1" i="0">
+                <a:solidFill>
+                  <a:srgbClr val="243343"/>
+                </a:solidFill>
+                <a:latin typeface="Arial"/>
+              </a:rPr>
+              <a:t>Biomechanics</a:t>
+            </a:r>
+          </a:p>
+        </p:txBody>
+      </p:sp>
+      <p:sp>
+        <p:nvSpPr>
+          <p:cNvPr id="8" name="TextBox 7"/>
+          <p:cNvSpPr txBox="1"/>
+          <p:nvPr/>
+        </p:nvSpPr>
+        <p:spPr>
+          <a:xfrm>
+            <a:off x="444500" y="959612"/>
+            <a:ext cx="1244600" cy="318211"/>
+          </a:xfrm>
+          <a:prstGeom prst="rect">
+            <a:avLst/>
+          </a:prstGeom>
+          <a:noFill/>
+        </p:spPr>
+        <p:txBody>
+          <a:bodyPr wrap="none" lIns="0" rIns="0" tIns="0" bIns="0">
+            <a:noAutofit/>
+          </a:bodyPr>
+          <a:lstStyle/>
+          <a:p>
+            <a:pPr algn="ctr">
+              <a:lnSpc>
+                <a:spcPts val="1188"/>
+              </a:lnSpc>
+              <a:spcBef>
+                <a:spcPts val="0"/>
+              </a:spcBef>
+              <a:spcAft>
+                <a:spcPts val="0"/>
+              </a:spcAft>
+            </a:pPr>
+            <a:r>
+              <a:rPr sz="1080" b="0" i="0">
+                <a:solidFill>
+                  <a:srgbClr val="243343"/>
+                </a:solidFill>
+                <a:latin typeface="Arial"/>
+              </a:rPr>
+              <a:t>Human benchmark</a:t>
+            </a:r>
+          </a:p>
+          <a:p>
+            <a:pPr algn="ctr">
+              <a:lnSpc>
+                <a:spcPts val="1188"/>
+              </a:lnSpc>
+              <a:spcBef>
+                <a:spcPts val="0"/>
+              </a:spcBef>
+              <a:spcAft>
+                <a:spcPts val="0"/>
+              </a:spcAft>
+            </a:pPr>
+            <a:r>
+              <a:rPr sz="1080" b="0" i="0">
+                <a:solidFill>
+                  <a:srgbClr val="243343"/>
+                </a:solidFill>
+                <a:latin typeface="Arial"/>
+              </a:rPr>
+              <a:t>(Ch. 2)</a:t>
+            </a:r>
+          </a:p>
+        </p:txBody>
+      </p:sp>
+      <p:sp>
+        <p:nvSpPr>
+          <p:cNvPr id="9" name="Rectangle 8"/>
+          <p:cNvSpPr/>
+          <p:nvPr/>
+        </p:nvSpPr>
+        <p:spPr>
+          <a:xfrm>
+            <a:off x="2260600" y="673100"/>
+            <a:ext cx="1422400" cy="647700"/>
+          </a:xfrm>
+          <a:prstGeom prst="rect">
+            <a:avLst/>
+          </a:prstGeom>
+          <a:solidFill>
+            <a:srgbClr val="F1F5F8"/>
+          </a:solidFill>
+          <a:ln w="12700">
+            <a:solidFill>
+              <a:srgbClr val="243343"/>
+            </a:solidFill>
+          </a:ln>
+        </p:spPr>
+        <p:style>
+          <a:lnRef idx="1">
+            <a:schemeClr val="accent1"/>
+          </a:lnRef>
+          <a:fillRef idx="3">
+            <a:schemeClr val="accent1"/>
+          </a:fillRef>
+          <a:effectRef idx="2">
+            <a:schemeClr val="accent1"/>
+          </a:effectRef>
+          <a:fontRef idx="minor">
+            <a:schemeClr val="lt1"/>
+          </a:fontRef>
+        </p:style>
+        <p:txBody>
+          <a:bodyPr rtlCol="0" anchor="ctr"/>
+          <a:lstStyle/>
+          <a:p>
+            <a:pPr algn="ctr"/>
+          </a:p>
+        </p:txBody>
+      </p:sp>
+      <p:sp>
+        <p:nvSpPr>
+          <p:cNvPr id="10" name="TextBox 9"/>
+          <p:cNvSpPr txBox="1"/>
+          <p:nvPr/>
+        </p:nvSpPr>
+        <p:spPr>
+          <a:xfrm>
+            <a:off x="2349500" y="745235"/>
+            <a:ext cx="1244600" cy="157734"/>
+          </a:xfrm>
+          <a:prstGeom prst="rect">
+            <a:avLst/>
+          </a:prstGeom>
+          <a:noFill/>
+        </p:spPr>
+        <p:txBody>
+          <a:bodyPr wrap="none" lIns="0" rIns="0" tIns="0" bIns="0">
+            <a:noAutofit/>
+          </a:bodyPr>
+          <a:lstStyle/>
+          <a:p>
+            <a:pPr algn="ctr">
+              <a:lnSpc>
+                <a:spcPts val="1188"/>
+              </a:lnSpc>
+              <a:spcBef>
+                <a:spcPts val="0"/>
+              </a:spcBef>
+              <a:spcAft>
+                <a:spcPts val="0"/>
+              </a:spcAft>
+            </a:pPr>
+            <a:r>
+              <a:rPr sz="1080" b="1" i="0">
+                <a:solidFill>
+                  <a:srgbClr val="243343"/>
+                </a:solidFill>
+                <a:latin typeface="Arial"/>
+              </a:rPr>
+              <a:t>BPA force models</a:t>
+            </a:r>
+          </a:p>
+        </p:txBody>
+      </p:sp>
+      <p:sp>
+        <p:nvSpPr>
+          <p:cNvPr id="11" name="TextBox 10"/>
+          <p:cNvSpPr txBox="1"/>
+          <p:nvPr/>
+        </p:nvSpPr>
+        <p:spPr>
+          <a:xfrm>
+            <a:off x="2349500" y="959612"/>
+            <a:ext cx="1244600" cy="318211"/>
+          </a:xfrm>
+          <a:prstGeom prst="rect">
+            <a:avLst/>
+          </a:prstGeom>
+          <a:noFill/>
+        </p:spPr>
+        <p:txBody>
+          <a:bodyPr wrap="none" lIns="0" rIns="0" tIns="0" bIns="0">
+            <a:noAutofit/>
+          </a:bodyPr>
+          <a:lstStyle/>
+          <a:p>
+            <a:pPr algn="ctr">
+              <a:lnSpc>
+                <a:spcPts val="1188"/>
+              </a:lnSpc>
+              <a:spcBef>
+                <a:spcPts val="0"/>
+              </a:spcBef>
+              <a:spcAft>
+                <a:spcPts val="0"/>
+              </a:spcAft>
+            </a:pPr>
+            <a:r>
+              <a:rPr sz="1080" b="0" i="0">
+                <a:solidFill>
+                  <a:srgbClr val="243343"/>
+                </a:solidFill>
+                <a:latin typeface="Arial"/>
+              </a:rPr>
+              <a:t>Characterization</a:t>
+            </a:r>
+          </a:p>
+          <a:p>
+            <a:pPr algn="ctr">
+              <a:lnSpc>
+                <a:spcPts val="1188"/>
+              </a:lnSpc>
+              <a:spcBef>
+                <a:spcPts val="0"/>
+              </a:spcBef>
+              <a:spcAft>
+                <a:spcPts val="0"/>
+              </a:spcAft>
+            </a:pPr>
+            <a:r>
+              <a:rPr sz="1080" b="0" i="0">
+                <a:solidFill>
+                  <a:srgbClr val="243343"/>
+                </a:solidFill>
+                <a:latin typeface="Arial"/>
+              </a:rPr>
+              <a:t>(Ch. 3)</a:t>
+            </a:r>
+          </a:p>
+        </p:txBody>
+      </p:sp>
+      <p:sp>
+        <p:nvSpPr>
+          <p:cNvPr id="12" name="Rectangle 11"/>
+          <p:cNvSpPr/>
+          <p:nvPr/>
+        </p:nvSpPr>
+        <p:spPr>
+          <a:xfrm>
+            <a:off x="4165600" y="673100"/>
+            <a:ext cx="1422400" cy="647700"/>
+          </a:xfrm>
+          <a:prstGeom prst="rect">
+            <a:avLst/>
+          </a:prstGeom>
+          <a:solidFill>
+            <a:srgbClr val="F1F5F8"/>
+          </a:solidFill>
+          <a:ln w="12700">
+            <a:solidFill>
+              <a:srgbClr val="243343"/>
+            </a:solidFill>
+          </a:ln>
+        </p:spPr>
+        <p:style>
+          <a:lnRef idx="1">
+            <a:schemeClr val="accent1"/>
+          </a:lnRef>
+          <a:fillRef idx="3">
+            <a:schemeClr val="accent1"/>
+          </a:fillRef>
+          <a:effectRef idx="2">
+            <a:schemeClr val="accent1"/>
+          </a:effectRef>
+          <a:fontRef idx="minor">
+            <a:schemeClr val="lt1"/>
+          </a:fontRef>
+        </p:style>
+        <p:txBody>
+          <a:bodyPr rtlCol="0" anchor="ctr"/>
+          <a:lstStyle/>
+          <a:p>
+            <a:pPr algn="ctr"/>
+          </a:p>
+        </p:txBody>
+      </p:sp>
+      <p:sp>
+        <p:nvSpPr>
+          <p:cNvPr id="13" name="TextBox 12"/>
+          <p:cNvSpPr txBox="1"/>
+          <p:nvPr/>
+        </p:nvSpPr>
+        <p:spPr>
+          <a:xfrm>
+            <a:off x="4254500" y="745235"/>
+            <a:ext cx="1244600" cy="157734"/>
+          </a:xfrm>
+          <a:prstGeom prst="rect">
+            <a:avLst/>
+          </a:prstGeom>
+          <a:noFill/>
+        </p:spPr>
+        <p:txBody>
+          <a:bodyPr wrap="none" lIns="0" rIns="0" tIns="0" bIns="0">
+            <a:noAutofit/>
+          </a:bodyPr>
+          <a:lstStyle/>
+          <a:p>
+            <a:pPr algn="ctr">
+              <a:lnSpc>
+                <a:spcPts val="1188"/>
+              </a:lnSpc>
+              <a:spcBef>
+                <a:spcPts val="0"/>
+              </a:spcBef>
+              <a:spcAft>
+                <a:spcPts val="0"/>
+              </a:spcAft>
+            </a:pPr>
+            <a:r>
+              <a:rPr sz="1080" b="1" i="0">
+                <a:solidFill>
+                  <a:srgbClr val="243343"/>
+                </a:solidFill>
+                <a:latin typeface="Arial"/>
+              </a:rPr>
+              <a:t>Torque model</a:t>
+            </a:r>
+          </a:p>
+        </p:txBody>
+      </p:sp>
+      <p:sp>
+        <p:nvSpPr>
+          <p:cNvPr id="14" name="TextBox 13"/>
+          <p:cNvSpPr txBox="1"/>
+          <p:nvPr/>
+        </p:nvSpPr>
+        <p:spPr>
+          <a:xfrm>
+            <a:off x="4254500" y="959612"/>
+            <a:ext cx="1244600" cy="318211"/>
+          </a:xfrm>
+          <a:prstGeom prst="rect">
+            <a:avLst/>
+          </a:prstGeom>
+          <a:noFill/>
+        </p:spPr>
+        <p:txBody>
+          <a:bodyPr wrap="none" lIns="0" rIns="0" tIns="0" bIns="0">
+            <a:noAutofit/>
+          </a:bodyPr>
+          <a:lstStyle/>
+          <a:p>
+            <a:pPr algn="ctr">
+              <a:lnSpc>
+                <a:spcPts val="1188"/>
+              </a:lnSpc>
+              <a:spcBef>
+                <a:spcPts val="0"/>
+              </a:spcBef>
+              <a:spcAft>
+                <a:spcPts val="0"/>
+              </a:spcAft>
+            </a:pPr>
+            <a:r>
+              <a:rPr sz="1080" b="0" i="0">
+                <a:solidFill>
+                  <a:srgbClr val="243343"/>
+                </a:solidFill>
+                <a:latin typeface="Arial"/>
+              </a:rPr>
+              <a:t>Corrections, routes</a:t>
+            </a:r>
+          </a:p>
+          <a:p>
+            <a:pPr algn="ctr">
+              <a:lnSpc>
+                <a:spcPts val="1188"/>
+              </a:lnSpc>
+              <a:spcBef>
+                <a:spcPts val="0"/>
+              </a:spcBef>
+              <a:spcAft>
+                <a:spcPts val="0"/>
+              </a:spcAft>
+            </a:pPr>
+            <a:r>
+              <a:rPr sz="1080" b="0" i="0">
+                <a:solidFill>
+                  <a:srgbClr val="243343"/>
+                </a:solidFill>
+                <a:latin typeface="Arial"/>
+              </a:rPr>
+              <a:t>(Ch. 4)</a:t>
+            </a:r>
+          </a:p>
+        </p:txBody>
+      </p:sp>
+      <p:sp>
+        <p:nvSpPr>
+          <p:cNvPr id="15" name="Rectangle 14"/>
+          <p:cNvSpPr/>
+          <p:nvPr/>
+        </p:nvSpPr>
+        <p:spPr>
+          <a:xfrm>
+            <a:off x="355600" y="1943100"/>
+            <a:ext cx="1422400" cy="647700"/>
+          </a:xfrm>
+          <a:prstGeom prst="rect">
+            <a:avLst/>
+          </a:prstGeom>
+          <a:solidFill>
+            <a:srgbClr val="F1F5F8"/>
+          </a:solidFill>
+          <a:ln w="12700">
+            <a:solidFill>
+              <a:srgbClr val="243343"/>
+            </a:solidFill>
+          </a:ln>
+        </p:spPr>
+        <p:style>
+          <a:lnRef idx="1">
+            <a:schemeClr val="accent1"/>
+          </a:lnRef>
+          <a:fillRef idx="3">
+            <a:schemeClr val="accent1"/>
+          </a:fillRef>
+          <a:effectRef idx="2">
+            <a:schemeClr val="accent1"/>
+          </a:effectRef>
+          <a:fontRef idx="minor">
+            <a:schemeClr val="lt1"/>
+          </a:fontRef>
+        </p:style>
+        <p:txBody>
+          <a:bodyPr rtlCol="0" anchor="ctr"/>
+          <a:lstStyle/>
+          <a:p>
+            <a:pPr algn="ctr"/>
+          </a:p>
+        </p:txBody>
+      </p:sp>
+      <p:sp>
+        <p:nvSpPr>
+          <p:cNvPr id="16" name="TextBox 15"/>
+          <p:cNvSpPr txBox="1"/>
+          <p:nvPr/>
+        </p:nvSpPr>
+        <p:spPr>
+          <a:xfrm>
+            <a:off x="444500" y="2015236"/>
+            <a:ext cx="1244600" cy="315468"/>
+          </a:xfrm>
+          <a:prstGeom prst="rect">
+            <a:avLst/>
+          </a:prstGeom>
+          <a:noFill/>
+        </p:spPr>
+        <p:txBody>
+          <a:bodyPr wrap="none" lIns="0" rIns="0" tIns="0" bIns="0">
+            <a:noAutofit/>
+          </a:bodyPr>
+          <a:lstStyle/>
+          <a:p>
+            <a:pPr algn="ctr">
+              <a:lnSpc>
+                <a:spcPts val="1188"/>
+              </a:lnSpc>
+              <a:spcBef>
+                <a:spcPts val="0"/>
+              </a:spcBef>
+              <a:spcAft>
+                <a:spcPts val="0"/>
+              </a:spcAft>
+            </a:pPr>
+            <a:r>
+              <a:rPr sz="1080" b="1" i="0">
+                <a:solidFill>
+                  <a:srgbClr val="243343"/>
+                </a:solidFill>
+                <a:latin typeface="Arial"/>
+              </a:rPr>
+              <a:t>Sensory Afferent</a:t>
+            </a:r>
+          </a:p>
+          <a:p>
+            <a:pPr algn="ctr">
+              <a:lnSpc>
+                <a:spcPts val="1188"/>
+              </a:lnSpc>
+              <a:spcBef>
+                <a:spcPts val="0"/>
+              </a:spcBef>
+              <a:spcAft>
+                <a:spcPts val="0"/>
+              </a:spcAft>
+            </a:pPr>
+            <a:r>
+              <a:rPr sz="1080" b="1" i="0">
+                <a:solidFill>
+                  <a:srgbClr val="243343"/>
+                </a:solidFill>
+                <a:latin typeface="Arial"/>
+              </a:rPr>
+              <a:t>Database</a:t>
+            </a:r>
+          </a:p>
+        </p:txBody>
+      </p:sp>
+      <p:sp>
+        <p:nvSpPr>
+          <p:cNvPr id="17" name="TextBox 16"/>
+          <p:cNvSpPr txBox="1"/>
+          <p:nvPr/>
+        </p:nvSpPr>
+        <p:spPr>
+          <a:xfrm>
+            <a:off x="444500" y="2380488"/>
+            <a:ext cx="1244600" cy="159105"/>
+          </a:xfrm>
+          <a:prstGeom prst="rect">
+            <a:avLst/>
+          </a:prstGeom>
+          <a:noFill/>
+        </p:spPr>
+        <p:txBody>
+          <a:bodyPr wrap="none" lIns="0" rIns="0" tIns="0" bIns="0">
+            <a:noAutofit/>
+          </a:bodyPr>
+          <a:lstStyle/>
+          <a:p>
+            <a:pPr algn="ctr">
+              <a:lnSpc>
+                <a:spcPts val="1188"/>
+              </a:lnSpc>
+              <a:spcBef>
+                <a:spcPts val="0"/>
+              </a:spcBef>
+              <a:spcAft>
+                <a:spcPts val="0"/>
+              </a:spcAft>
+            </a:pPr>
+            <a:r>
+              <a:rPr sz="1080" b="0" i="0">
+                <a:solidFill>
+                  <a:srgbClr val="243343"/>
+                </a:solidFill>
+                <a:latin typeface="Arial"/>
+              </a:rPr>
+              <a:t>Pathways (Ch. 5)</a:t>
+            </a:r>
+          </a:p>
+        </p:txBody>
+      </p:sp>
+      <p:sp>
+        <p:nvSpPr>
+          <p:cNvPr id="18" name="Rectangle 17"/>
+          <p:cNvSpPr/>
+          <p:nvPr/>
+        </p:nvSpPr>
+        <p:spPr>
+          <a:xfrm>
+            <a:off x="2260600" y="1943100"/>
+            <a:ext cx="1422400" cy="647700"/>
+          </a:xfrm>
+          <a:prstGeom prst="rect">
+            <a:avLst/>
+          </a:prstGeom>
+          <a:solidFill>
+            <a:srgbClr val="F1F5F8"/>
+          </a:solidFill>
+          <a:ln w="12700">
+            <a:solidFill>
+              <a:srgbClr val="243343"/>
+            </a:solidFill>
+          </a:ln>
+        </p:spPr>
+        <p:style>
+          <a:lnRef idx="1">
+            <a:schemeClr val="accent1"/>
+          </a:lnRef>
+          <a:fillRef idx="3">
+            <a:schemeClr val="accent1"/>
+          </a:fillRef>
+          <a:effectRef idx="2">
+            <a:schemeClr val="accent1"/>
+          </a:effectRef>
+          <a:fontRef idx="minor">
+            <a:schemeClr val="lt1"/>
+          </a:fontRef>
+        </p:style>
+        <p:txBody>
+          <a:bodyPr rtlCol="0" anchor="ctr"/>
+          <a:lstStyle/>
+          <a:p>
+            <a:pPr algn="ctr"/>
+          </a:p>
+        </p:txBody>
+      </p:sp>
+      <p:sp>
+        <p:nvSpPr>
+          <p:cNvPr id="19" name="TextBox 18"/>
+          <p:cNvSpPr txBox="1"/>
+          <p:nvPr/>
+        </p:nvSpPr>
+        <p:spPr>
+          <a:xfrm>
+            <a:off x="2349500" y="2015236"/>
+            <a:ext cx="1244600" cy="157734"/>
+          </a:xfrm>
+          <a:prstGeom prst="rect">
+            <a:avLst/>
+          </a:prstGeom>
+          <a:noFill/>
+        </p:spPr>
+        <p:txBody>
+          <a:bodyPr wrap="none" lIns="0" rIns="0" tIns="0" bIns="0">
+            <a:noAutofit/>
+          </a:bodyPr>
+          <a:lstStyle/>
+          <a:p>
+            <a:pPr algn="ctr">
+              <a:lnSpc>
+                <a:spcPts val="1188"/>
+              </a:lnSpc>
+              <a:spcBef>
+                <a:spcPts val="0"/>
+              </a:spcBef>
+              <a:spcAft>
+                <a:spcPts val="0"/>
+              </a:spcAft>
+            </a:pPr>
+            <a:r>
+              <a:rPr sz="1080" b="1" i="0">
+                <a:solidFill>
+                  <a:srgbClr val="243343"/>
+                </a:solidFill>
+                <a:latin typeface="Arial"/>
+              </a:rPr>
+              <a:t>SNS simulation</a:t>
+            </a:r>
+          </a:p>
+        </p:txBody>
+      </p:sp>
+      <p:sp>
+        <p:nvSpPr>
+          <p:cNvPr id="20" name="TextBox 19"/>
+          <p:cNvSpPr txBox="1"/>
+          <p:nvPr/>
+        </p:nvSpPr>
+        <p:spPr>
+          <a:xfrm>
+            <a:off x="2349500" y="2229612"/>
+            <a:ext cx="1244600" cy="318211"/>
+          </a:xfrm>
+          <a:prstGeom prst="rect">
+            <a:avLst/>
+          </a:prstGeom>
+          <a:noFill/>
+        </p:spPr>
+        <p:txBody>
+          <a:bodyPr wrap="none" lIns="0" rIns="0" tIns="0" bIns="0">
+            <a:noAutofit/>
+          </a:bodyPr>
+          <a:lstStyle/>
+          <a:p>
+            <a:pPr algn="ctr">
+              <a:lnSpc>
+                <a:spcPts val="1188"/>
+              </a:lnSpc>
+              <a:spcBef>
+                <a:spcPts val="0"/>
+              </a:spcBef>
+              <a:spcAft>
+                <a:spcPts val="0"/>
+              </a:spcAft>
+            </a:pPr>
+            <a:r>
+              <a:rPr sz="1080" b="0" i="0">
+                <a:solidFill>
+                  <a:srgbClr val="243343"/>
+                </a:solidFill>
+                <a:latin typeface="Arial"/>
+              </a:rPr>
+              <a:t>Software tools</a:t>
+            </a:r>
+          </a:p>
+          <a:p>
+            <a:pPr algn="ctr">
+              <a:lnSpc>
+                <a:spcPts val="1188"/>
+              </a:lnSpc>
+              <a:spcBef>
+                <a:spcPts val="0"/>
+              </a:spcBef>
+              <a:spcAft>
+                <a:spcPts val="0"/>
+              </a:spcAft>
+            </a:pPr>
+            <a:r>
+              <a:rPr sz="1080" b="0" i="0">
+                <a:solidFill>
+                  <a:srgbClr val="243343"/>
+                </a:solidFill>
+                <a:latin typeface="Arial"/>
+              </a:rPr>
+              <a:t>(Ch. 6)</a:t>
+            </a:r>
+          </a:p>
+        </p:txBody>
+      </p:sp>
+      <p:sp>
+        <p:nvSpPr>
+          <p:cNvPr id="21" name="Rectangle 20"/>
+          <p:cNvSpPr/>
+          <p:nvPr/>
+        </p:nvSpPr>
+        <p:spPr>
+          <a:xfrm>
+            <a:off x="4165600" y="1943100"/>
+            <a:ext cx="1422400" cy="647700"/>
+          </a:xfrm>
+          <a:prstGeom prst="rect">
+            <a:avLst/>
+          </a:prstGeom>
+          <a:solidFill>
+            <a:srgbClr val="F1F5F8"/>
+          </a:solidFill>
+          <a:ln w="12700">
+            <a:solidFill>
+              <a:srgbClr val="243343"/>
+            </a:solidFill>
+            <a:prstDash val="dash"/>
+          </a:ln>
+        </p:spPr>
+        <p:style>
+          <a:lnRef idx="1">
+            <a:schemeClr val="accent1"/>
+          </a:lnRef>
+          <a:fillRef idx="3">
+            <a:schemeClr val="accent1"/>
+          </a:fillRef>
+          <a:effectRef idx="2">
+            <a:schemeClr val="accent1"/>
+          </a:effectRef>
+          <a:fontRef idx="minor">
+            <a:schemeClr val="lt1"/>
+          </a:fontRef>
+        </p:style>
+        <p:txBody>
+          <a:bodyPr rtlCol="0" anchor="ctr"/>
+          <a:lstStyle/>
+          <a:p>
+            <a:pPr algn="ctr"/>
+          </a:p>
+        </p:txBody>
+      </p:sp>
+      <p:sp>
+        <p:nvSpPr>
+          <p:cNvPr id="22" name="TextBox 21"/>
+          <p:cNvSpPr txBox="1"/>
+          <p:nvPr/>
+        </p:nvSpPr>
+        <p:spPr>
+          <a:xfrm>
+            <a:off x="4254500" y="2015236"/>
+            <a:ext cx="1244600" cy="157734"/>
+          </a:xfrm>
+          <a:prstGeom prst="rect">
+            <a:avLst/>
+          </a:prstGeom>
+          <a:noFill/>
+        </p:spPr>
+        <p:txBody>
+          <a:bodyPr wrap="none" lIns="0" rIns="0" tIns="0" bIns="0">
+            <a:noAutofit/>
+          </a:bodyPr>
+          <a:lstStyle/>
+          <a:p>
+            <a:pPr algn="ctr">
+              <a:lnSpc>
+                <a:spcPts val="1188"/>
+              </a:lnSpc>
+              <a:spcBef>
+                <a:spcPts val="0"/>
+              </a:spcBef>
+              <a:spcAft>
+                <a:spcPts val="0"/>
+              </a:spcAft>
+            </a:pPr>
+            <a:r>
+              <a:rPr sz="1080" b="1" i="0">
+                <a:solidFill>
+                  <a:srgbClr val="243343"/>
+                </a:solidFill>
+                <a:latin typeface="Arial"/>
+              </a:rPr>
+              <a:t>BPA robot</a:t>
+            </a:r>
+          </a:p>
+        </p:txBody>
+      </p:sp>
+      <p:sp>
+        <p:nvSpPr>
+          <p:cNvPr id="23" name="TextBox 22"/>
+          <p:cNvSpPr txBox="1"/>
+          <p:nvPr/>
+        </p:nvSpPr>
+        <p:spPr>
+          <a:xfrm>
+            <a:off x="4254500" y="2229612"/>
+            <a:ext cx="1244600" cy="318211"/>
+          </a:xfrm>
+          <a:prstGeom prst="rect">
+            <a:avLst/>
+          </a:prstGeom>
+          <a:noFill/>
+        </p:spPr>
+        <p:txBody>
+          <a:bodyPr wrap="none" lIns="0" rIns="0" tIns="0" bIns="0">
+            <a:noAutofit/>
+          </a:bodyPr>
+          <a:lstStyle/>
+          <a:p>
+            <a:pPr algn="ctr">
+              <a:lnSpc>
+                <a:spcPts val="1188"/>
+              </a:lnSpc>
+              <a:spcBef>
+                <a:spcPts val="0"/>
+              </a:spcBef>
+              <a:spcAft>
+                <a:spcPts val="0"/>
+              </a:spcAft>
+            </a:pPr>
+            <a:r>
+              <a:rPr sz="1080" b="0" i="0">
+                <a:solidFill>
+                  <a:srgbClr val="243343"/>
+                </a:solidFill>
+                <a:latin typeface="Arial"/>
+              </a:rPr>
+              <a:t>SNS control</a:t>
+            </a:r>
+          </a:p>
+          <a:p>
+            <a:pPr algn="ctr">
+              <a:lnSpc>
+                <a:spcPts val="1188"/>
+              </a:lnSpc>
+              <a:spcBef>
+                <a:spcPts val="0"/>
+              </a:spcBef>
+              <a:spcAft>
+                <a:spcPts val="0"/>
+              </a:spcAft>
+            </a:pPr>
+            <a:r>
+              <a:rPr sz="1080" b="0" i="0">
+                <a:solidFill>
+                  <a:srgbClr val="243343"/>
+                </a:solidFill>
+                <a:latin typeface="Arial"/>
+              </a:rPr>
+              <a:t>(future work)</a:t>
             </a:r>
           </a:p>
         </p:txBody>
       </p:sp>
       <p:cxnSp>
         <p:nvCxnSpPr>
-          <p:cNvPr id="12" name="Connector 11"/>
+          <p:cNvPr id="24" name="Connector 23"/>
           <p:cNvCxnSpPr/>
           <p:nvPr/>
         </p:nvCxnSpPr>
         <p:spPr>
           <a:xfrm>
-            <a:off x="1673999" y="2043000"/>
-            <a:ext cx="504001" cy="0"/>
+            <a:off x="1778000" y="996950"/>
+            <a:ext cx="482600" cy="0"/>
           </a:xfrm>
           <a:prstGeom prst="line">
             <a:avLst/>
           </a:prstGeom>
           <a:ln w="12700">
             <a:solidFill>
-              <a:srgbClr val="1F1F1F"/>
+              <a:srgbClr val="243343"/>
             </a:solidFill>
-            <a:tailEnd type="triangle" w="med" len="med"/>
-          </a:ln>
-        </p:spPr>
-        <p:style>
-          <a:lnRef idx="2">
-            <a:schemeClr val="accent1"/>
-          </a:lnRef>
-          <a:fillRef idx="0">
-            <a:schemeClr val="accent1"/>
-          </a:fillRef>
-          <a:effectRef idx="1">
-            <a:schemeClr val="accent1"/>
-          </a:effectRef>
-          <a:fontRef idx="minor">
-            <a:schemeClr val="tx1"/>
-          </a:fontRef>
-        </p:style>
-      </p:cxnSp>
-      <p:sp>
-        <p:nvSpPr>
-          <p:cNvPr id="13" name="TextBox 12"/>
-          <p:cNvSpPr txBox="1"/>
-          <p:nvPr/>
-        </p:nvSpPr>
-        <p:spPr>
-          <a:xfrm>
-            <a:off x="1673999" y="1530000"/>
-            <a:ext cx="522000" cy="270000"/>
-          </a:xfrm>
-          <a:prstGeom prst="rect">
-            <a:avLst/>
-          </a:prstGeom>
-          <a:noFill/>
-        </p:spPr>
-        <p:txBody>
-          <a:bodyPr wrap="square" lIns="10800" rIns="10800" tIns="3600" bIns="3600">
-            <a:spAutoFit/>
-          </a:bodyPr>
-          <a:lstStyle/>
-          <a:p>
-            <a:pPr algn="ctr"/>
-            <a:r>
-              <a:rPr sz="1000" b="0">
-                <a:solidFill>
-                  <a:srgbClr val="1F1F1F"/>
-                </a:solidFill>
-                <a:latin typeface="Arial"/>
-              </a:rPr>
-              <a:t>sensory channels</a:t>
-            </a:r>
-          </a:p>
-        </p:txBody>
-      </p:sp>
-      <p:cxnSp>
-        <p:nvCxnSpPr>
-          <p:cNvPr id="14" name="Connector 13"/>
-          <p:cNvCxnSpPr/>
-          <p:nvPr/>
-        </p:nvCxnSpPr>
-        <p:spPr>
-          <a:xfrm>
-            <a:off x="3761999" y="2043000"/>
-            <a:ext cx="504001" cy="0"/>
-          </a:xfrm>
-          <a:prstGeom prst="line">
-            <a:avLst/>
-          </a:prstGeom>
-          <a:ln w="12700">
-            <a:solidFill>
-              <a:srgbClr val="1F1F1F"/>
-            </a:solidFill>
-            <a:tailEnd type="triangle" w="med" len="med"/>
-          </a:ln>
-        </p:spPr>
-        <p:style>
-          <a:lnRef idx="2">
-            <a:schemeClr val="accent1"/>
-          </a:lnRef>
-          <a:fillRef idx="0">
-            <a:schemeClr val="accent1"/>
-          </a:fillRef>
-          <a:effectRef idx="1">
-            <a:schemeClr val="accent1"/>
-          </a:effectRef>
-          <a:fontRef idx="minor">
-            <a:schemeClr val="tx1"/>
-          </a:fontRef>
-        </p:style>
-      </p:cxnSp>
-      <p:sp>
-        <p:nvSpPr>
-          <p:cNvPr id="15" name="TextBox 14"/>
-          <p:cNvSpPr txBox="1"/>
-          <p:nvPr/>
-        </p:nvSpPr>
-        <p:spPr>
-          <a:xfrm>
-            <a:off x="3761999" y="1530000"/>
-            <a:ext cx="522000" cy="270000"/>
-          </a:xfrm>
-          <a:prstGeom prst="rect">
-            <a:avLst/>
-          </a:prstGeom>
-          <a:noFill/>
-        </p:spPr>
-        <p:txBody>
-          <a:bodyPr wrap="square" lIns="10800" rIns="10800" tIns="3600" bIns="3600">
-            <a:spAutoFit/>
-          </a:bodyPr>
-          <a:lstStyle/>
-          <a:p>
-            <a:pPr algn="ctr"/>
-            <a:r>
-              <a:rPr sz="1000" b="0">
-                <a:solidFill>
-                  <a:srgbClr val="1F1F1F"/>
-                </a:solidFill>
-                <a:latin typeface="Arial"/>
-              </a:rPr>
-              <a:t>controller and</a:t>
-            </a:r>
-          </a:p>
-          <a:p>
-            <a:pPr algn="ctr"/>
-            <a:r>
-              <a:rPr sz="1000" b="0">
-                <a:solidFill>
-                  <a:srgbClr val="1F1F1F"/>
-                </a:solidFill>
-                <a:latin typeface="Arial"/>
-              </a:rPr>
-              <a:t>body model</a:t>
-            </a:r>
-          </a:p>
-        </p:txBody>
-      </p:sp>
-      <p:cxnSp>
-        <p:nvCxnSpPr>
-          <p:cNvPr id="16" name="Connector 15"/>
-          <p:cNvCxnSpPr/>
-          <p:nvPr/>
-        </p:nvCxnSpPr>
-        <p:spPr>
-          <a:xfrm>
-            <a:off x="5067000" y="1170000"/>
-            <a:ext cx="0" cy="198000"/>
-          </a:xfrm>
-          <a:prstGeom prst="line">
-            <a:avLst/>
-          </a:prstGeom>
-          <a:ln w="12700">
-            <a:solidFill>
-              <a:srgbClr val="1F1F1F"/>
-            </a:solidFill>
+            <a:tailEnd type="triangle" w="sm" len="sm"/>
           </a:ln>
         </p:spPr>
         <p:style>
@@ -3830,22 +4230,171 @@
       </p:cxnSp>
       <p:cxnSp>
         <p:nvCxnSpPr>
-          <p:cNvPr id="17" name="Connector 16"/>
+          <p:cNvPr id="25" name="Connector 24"/>
           <p:cNvCxnSpPr/>
           <p:nvPr/>
         </p:nvCxnSpPr>
         <p:spPr>
-          <a:xfrm flipH="1">
-            <a:off x="2978999" y="1368000"/>
-            <a:ext cx="2088001" cy="0"/>
+          <a:xfrm>
+            <a:off x="3683000" y="996950"/>
+            <a:ext cx="482600" cy="0"/>
           </a:xfrm>
           <a:prstGeom prst="line">
             <a:avLst/>
           </a:prstGeom>
           <a:ln w="12700">
             <a:solidFill>
-              <a:srgbClr val="1F1F1F"/>
+              <a:srgbClr val="243343"/>
             </a:solidFill>
+            <a:tailEnd type="triangle" w="sm" len="sm"/>
+          </a:ln>
+        </p:spPr>
+        <p:style>
+          <a:lnRef idx="2">
+            <a:schemeClr val="accent1"/>
+          </a:lnRef>
+          <a:fillRef idx="0">
+            <a:schemeClr val="accent1"/>
+          </a:fillRef>
+          <a:effectRef idx="1">
+            <a:schemeClr val="accent1"/>
+          </a:effectRef>
+          <a:fontRef idx="minor">
+            <a:schemeClr val="tx1"/>
+          </a:fontRef>
+        </p:style>
+      </p:cxnSp>
+      <p:sp>
+        <p:nvSpPr>
+          <p:cNvPr id="26" name="TextBox 25"/>
+          <p:cNvSpPr txBox="1"/>
+          <p:nvPr/>
+        </p:nvSpPr>
+        <p:spPr>
+          <a:xfrm>
+            <a:off x="1600200" y="381000"/>
+            <a:ext cx="838200" cy="355600"/>
+          </a:xfrm>
+          <a:prstGeom prst="rect">
+            <a:avLst/>
+          </a:prstGeom>
+          <a:noFill/>
+        </p:spPr>
+        <p:txBody>
+          <a:bodyPr wrap="none" lIns="0" rIns="0" tIns="0" bIns="0">
+            <a:noAutofit/>
+          </a:bodyPr>
+          <a:lstStyle/>
+          <a:p>
+            <a:pPr algn="ctr">
+              <a:lnSpc>
+                <a:spcPts val="1188"/>
+              </a:lnSpc>
+              <a:spcBef>
+                <a:spcPts val="0"/>
+              </a:spcBef>
+              <a:spcAft>
+                <a:spcPts val="0"/>
+              </a:spcAft>
+            </a:pPr>
+            <a:r>
+              <a:rPr sz="1080" b="0" i="0">
+                <a:solidFill>
+                  <a:srgbClr val="6C7680"/>
+                </a:solidFill>
+                <a:latin typeface="Arial"/>
+              </a:rPr>
+              <a:t>targets</a:t>
+            </a:r>
+          </a:p>
+        </p:txBody>
+      </p:sp>
+      <p:sp>
+        <p:nvSpPr>
+          <p:cNvPr id="27" name="TextBox 26"/>
+          <p:cNvSpPr txBox="1"/>
+          <p:nvPr/>
+        </p:nvSpPr>
+        <p:spPr>
+          <a:xfrm>
+            <a:off x="3479800" y="292100"/>
+            <a:ext cx="838200" cy="355600"/>
+          </a:xfrm>
+          <a:prstGeom prst="rect">
+            <a:avLst/>
+          </a:prstGeom>
+          <a:noFill/>
+        </p:spPr>
+        <p:txBody>
+          <a:bodyPr wrap="none" lIns="0" rIns="0" tIns="0" bIns="0">
+            <a:noAutofit/>
+          </a:bodyPr>
+          <a:lstStyle/>
+          <a:p>
+            <a:pPr algn="ctr">
+              <a:lnSpc>
+                <a:spcPts val="1188"/>
+              </a:lnSpc>
+              <a:spcBef>
+                <a:spcPts val="0"/>
+              </a:spcBef>
+              <a:spcAft>
+                <a:spcPts val="0"/>
+              </a:spcAft>
+            </a:pPr>
+            <a:r>
+              <a:rPr sz="1080" b="0" i="0">
+                <a:solidFill>
+                  <a:srgbClr val="6C7680"/>
+                </a:solidFill>
+                <a:latin typeface="Arial"/>
+              </a:rPr>
+              <a:t>actuator</a:t>
+            </a:r>
+          </a:p>
+          <a:p>
+            <a:pPr algn="ctr">
+              <a:lnSpc>
+                <a:spcPts val="1188"/>
+              </a:lnSpc>
+              <a:spcBef>
+                <a:spcPts val="0"/>
+              </a:spcBef>
+              <a:spcAft>
+                <a:spcPts val="0"/>
+              </a:spcAft>
+            </a:pPr>
+            <a:r>
+              <a:rPr sz="1080" b="0" i="0">
+                <a:solidFill>
+                  <a:srgbClr val="6C7680"/>
+                </a:solidFill>
+                <a:latin typeface="Arial"/>
+              </a:rPr>
+              <a:t>model</a:t>
+            </a:r>
+          </a:p>
+        </p:txBody>
+      </p:sp>
+      <p:cxnSp>
+        <p:nvCxnSpPr>
+          <p:cNvPr id="28" name="Connector 27"/>
+          <p:cNvCxnSpPr/>
+          <p:nvPr/>
+        </p:nvCxnSpPr>
+        <p:spPr>
+          <a:xfrm>
+            <a:off x="1778000" y="2266950"/>
+            <a:ext cx="482600" cy="0"/>
+          </a:xfrm>
+          <a:prstGeom prst="line">
+            <a:avLst/>
+          </a:prstGeom>
+          <a:ln w="12700">
+            <a:solidFill>
+              <a:srgbClr val="243343"/>
+            </a:solidFill>
+            <a:tailEnd type="triangle" w="sm" len="sm"/>
           </a:ln>
         </p:spPr>
         <p:style>
@@ -3865,105 +4414,24 @@
       </p:cxnSp>
       <p:cxnSp>
         <p:nvCxnSpPr>
-          <p:cNvPr id="18" name="Connector 17"/>
+          <p:cNvPr id="29" name="Connector 28"/>
           <p:cNvCxnSpPr/>
           <p:nvPr/>
         </p:nvCxnSpPr>
         <p:spPr>
           <a:xfrm>
-            <a:off x="2978999" y="1368000"/>
-            <a:ext cx="0" cy="378000"/>
+            <a:off x="3683000" y="2266950"/>
+            <a:ext cx="482600" cy="0"/>
           </a:xfrm>
           <a:prstGeom prst="line">
             <a:avLst/>
           </a:prstGeom>
           <a:ln w="12700">
             <a:solidFill>
-              <a:srgbClr val="1F1F1F"/>
+              <a:srgbClr val="243343"/>
             </a:solidFill>
-            <a:tailEnd type="triangle" w="med" len="med"/>
-          </a:ln>
-        </p:spPr>
-        <p:style>
-          <a:lnRef idx="2">
-            <a:schemeClr val="accent1"/>
-          </a:lnRef>
-          <a:fillRef idx="0">
-            <a:schemeClr val="accent1"/>
-          </a:fillRef>
-          <a:effectRef idx="1">
-            <a:schemeClr val="accent1"/>
-          </a:effectRef>
-          <a:fontRef idx="minor">
-            <a:schemeClr val="tx1"/>
-          </a:fontRef>
-        </p:style>
-      </p:cxnSp>
-      <p:sp>
-        <p:nvSpPr>
-          <p:cNvPr id="19" name="TextBox 18"/>
-          <p:cNvSpPr txBox="1"/>
-          <p:nvPr/>
-        </p:nvSpPr>
-        <p:spPr>
-          <a:xfrm>
-            <a:off x="5121000" y="1206000"/>
-            <a:ext cx="1224000" cy="270000"/>
-          </a:xfrm>
-          <a:prstGeom prst="rect">
-            <a:avLst/>
-          </a:prstGeom>
-          <a:noFill/>
-        </p:spPr>
-        <p:txBody>
-          <a:bodyPr wrap="square" lIns="10800" rIns="10800" tIns="3600" bIns="3600">
-            <a:spAutoFit/>
-          </a:bodyPr>
-          <a:lstStyle/>
-          <a:p>
-            <a:pPr algn="l"/>
-            <a:r>
-              <a:rPr sz="1000" b="0">
-                <a:solidFill>
-                  <a:srgbClr val="1F1F1F"/>
-                </a:solidFill>
-                <a:latin typeface="Arial"/>
-              </a:rPr>
-              <a:t>routes and</a:t>
-            </a:r>
-          </a:p>
-          <a:p>
-            <a:pPr algn="l"/>
-            <a:r>
-              <a:rPr sz="1000" b="0">
-                <a:solidFill>
-                  <a:srgbClr val="1F1F1F"/>
-                </a:solidFill>
-                <a:latin typeface="Arial"/>
-              </a:rPr>
-              <a:t>torque model</a:t>
-            </a:r>
-          </a:p>
-        </p:txBody>
-      </p:sp>
-      <p:cxnSp>
-        <p:nvCxnSpPr>
-          <p:cNvPr id="20" name="Connector 19"/>
-          <p:cNvCxnSpPr/>
-          <p:nvPr/>
-        </p:nvCxnSpPr>
-        <p:spPr>
-          <a:xfrm>
-            <a:off x="5067000" y="2322000"/>
-            <a:ext cx="0" cy="270000"/>
-          </a:xfrm>
-          <a:prstGeom prst="line">
-            <a:avLst/>
-          </a:prstGeom>
-          <a:ln w="12700">
-            <a:solidFill>
-              <a:srgbClr val="1F1F1F"/>
-            </a:solidFill>
+            <a:prstDash val="dash"/>
+            <a:tailEnd type="triangle" w="sm" len="sm"/>
           </a:ln>
         </p:spPr>
         <p:style>
@@ -3983,21 +4451,21 @@
       </p:cxnSp>
       <p:cxnSp>
         <p:nvCxnSpPr>
-          <p:cNvPr id="21" name="Connector 20"/>
+          <p:cNvPr id="30" name="Connector 29"/>
           <p:cNvCxnSpPr/>
           <p:nvPr/>
         </p:nvCxnSpPr>
         <p:spPr>
-          <a:xfrm flipH="1">
-            <a:off x="-306000" y="2592000"/>
-            <a:ext cx="5373000" cy="0"/>
+          <a:xfrm>
+            <a:off x="4876800" y="1320800"/>
+            <a:ext cx="0" cy="279400"/>
           </a:xfrm>
           <a:prstGeom prst="line">
             <a:avLst/>
           </a:prstGeom>
           <a:ln w="12700">
             <a:solidFill>
-              <a:srgbClr val="1F1F1F"/>
+              <a:srgbClr val="243343"/>
             </a:solidFill>
           </a:ln>
         </p:spPr>
@@ -4018,21 +4486,21 @@
       </p:cxnSp>
       <p:cxnSp>
         <p:nvCxnSpPr>
-          <p:cNvPr id="22" name="Connector 21"/>
+          <p:cNvPr id="31" name="Connector 30"/>
           <p:cNvCxnSpPr/>
           <p:nvPr/>
         </p:nvCxnSpPr>
         <p:spPr>
-          <a:xfrm>
-            <a:off x="-306000" y="2592000"/>
-            <a:ext cx="108000" cy="0"/>
+          <a:xfrm flipH="1">
+            <a:off x="2971800" y="1600200"/>
+            <a:ext cx="1905000" cy="0"/>
           </a:xfrm>
           <a:prstGeom prst="line">
             <a:avLst/>
           </a:prstGeom>
           <a:ln w="12700">
             <a:solidFill>
-              <a:srgbClr val="1F1F1F"/>
+              <a:srgbClr val="243343"/>
             </a:solidFill>
           </a:ln>
         </p:spPr>
@@ -4053,22 +4521,104 @@
       </p:cxnSp>
       <p:cxnSp>
         <p:nvCxnSpPr>
-          <p:cNvPr id="23" name="Connector 22"/>
+          <p:cNvPr id="32" name="Connector 31"/>
           <p:cNvCxnSpPr/>
           <p:nvPr/>
         </p:nvCxnSpPr>
         <p:spPr>
-          <a:xfrm flipV="1">
-            <a:off x="-198000" y="891000"/>
-            <a:ext cx="0" cy="1701000"/>
+          <a:xfrm>
+            <a:off x="2971800" y="1600200"/>
+            <a:ext cx="0" cy="342900"/>
           </a:xfrm>
           <a:prstGeom prst="line">
             <a:avLst/>
           </a:prstGeom>
           <a:ln w="12700">
             <a:solidFill>
-              <a:srgbClr val="1F1F1F"/>
+              <a:srgbClr val="243343"/>
             </a:solidFill>
+            <a:tailEnd type="triangle" w="sm" len="sm"/>
+          </a:ln>
+        </p:spPr>
+        <p:style>
+          <a:lnRef idx="2">
+            <a:schemeClr val="accent1"/>
+          </a:lnRef>
+          <a:fillRef idx="0">
+            <a:schemeClr val="accent1"/>
+          </a:fillRef>
+          <a:effectRef idx="1">
+            <a:schemeClr val="accent1"/>
+          </a:effectRef>
+          <a:fontRef idx="minor">
+            <a:schemeClr val="tx1"/>
+          </a:fontRef>
+        </p:style>
+      </p:cxnSp>
+      <p:sp>
+        <p:nvSpPr>
+          <p:cNvPr id="33" name="TextBox 32"/>
+          <p:cNvSpPr txBox="1"/>
+          <p:nvPr/>
+        </p:nvSpPr>
+        <p:spPr>
+          <a:xfrm>
+            <a:off x="3238500" y="1663700"/>
+            <a:ext cx="2273300" cy="177800"/>
+          </a:xfrm>
+          <a:prstGeom prst="rect">
+            <a:avLst/>
+          </a:prstGeom>
+          <a:noFill/>
+        </p:spPr>
+        <p:txBody>
+          <a:bodyPr wrap="none" lIns="0" rIns="0" tIns="0" bIns="0">
+            <a:noAutofit/>
+          </a:bodyPr>
+          <a:lstStyle/>
+          <a:p>
+            <a:pPr algn="r">
+              <a:lnSpc>
+                <a:spcPts val="1188"/>
+              </a:lnSpc>
+              <a:spcBef>
+                <a:spcPts val="0"/>
+              </a:spcBef>
+              <a:spcAft>
+                <a:spcPts val="0"/>
+              </a:spcAft>
+            </a:pPr>
+            <a:r>
+              <a:rPr sz="1080" b="0" i="0">
+                <a:solidFill>
+                  <a:srgbClr val="243343"/>
+                </a:solidFill>
+                <a:latin typeface="Arial"/>
+              </a:rPr>
+              <a:t>Routes and torque model</a:t>
+            </a:r>
+          </a:p>
+        </p:txBody>
+      </p:sp>
+      <p:cxnSp>
+        <p:nvCxnSpPr>
+          <p:cNvPr id="34" name="Connector 33"/>
+          <p:cNvCxnSpPr/>
+          <p:nvPr/>
+        </p:nvCxnSpPr>
+        <p:spPr>
+          <a:xfrm>
+            <a:off x="4876800" y="2590800"/>
+            <a:ext cx="0" cy="266700"/>
+          </a:xfrm>
+          <a:prstGeom prst="line">
+            <a:avLst/>
+          </a:prstGeom>
+          <a:ln w="12700">
+            <a:solidFill>
+              <a:srgbClr val="243343"/>
+            </a:solidFill>
+            <a:prstDash val="dash"/>
           </a:ln>
         </p:spPr>
         <p:style>
@@ -4088,23 +4638,23 @@
       </p:cxnSp>
       <p:cxnSp>
         <p:nvCxnSpPr>
-          <p:cNvPr id="24" name="Connector 23"/>
+          <p:cNvPr id="35" name="Connector 34"/>
           <p:cNvCxnSpPr/>
           <p:nvPr/>
         </p:nvCxnSpPr>
         <p:spPr>
-          <a:xfrm>
-            <a:off x="-198000" y="891000"/>
-            <a:ext cx="288000" cy="0"/>
+          <a:xfrm flipH="1">
+            <a:off x="152400" y="2857500"/>
+            <a:ext cx="4724400" cy="0"/>
           </a:xfrm>
           <a:prstGeom prst="line">
             <a:avLst/>
           </a:prstGeom>
           <a:ln w="12700">
             <a:solidFill>
-              <a:srgbClr val="1F1F1F"/>
+              <a:srgbClr val="243343"/>
             </a:solidFill>
-            <a:tailEnd type="triangle" w="med" len="med"/>
+            <a:prstDash val="dash"/>
           </a:ln>
         </p:spPr>
         <p:style>
@@ -4122,59 +4672,25 @@
           </a:fontRef>
         </p:style>
       </p:cxnSp>
-      <p:sp>
-        <p:nvSpPr>
-          <p:cNvPr id="25" name="TextBox 24"/>
-          <p:cNvSpPr txBox="1"/>
-          <p:nvPr/>
-        </p:nvSpPr>
-        <p:spPr>
-          <a:xfrm>
-            <a:off x="1620000" y="2368800"/>
-            <a:ext cx="2160000" cy="270000"/>
-          </a:xfrm>
-          <a:prstGeom prst="rect">
-            <a:avLst/>
-          </a:prstGeom>
-          <a:noFill/>
-        </p:spPr>
-        <p:txBody>
-          <a:bodyPr wrap="square" lIns="10800" rIns="10800" tIns="3600" bIns="3600">
-            <a:spAutoFit/>
-          </a:bodyPr>
-          <a:lstStyle/>
-          <a:p>
-            <a:pPr algn="ctr"/>
-            <a:r>
-              <a:rPr sz="1000" b="0">
-                <a:solidFill>
-                  <a:srgbClr val="1F1F1F"/>
-                </a:solidFill>
-                <a:latin typeface="Arial"/>
-              </a:rPr>
-              <a:t>biological insight</a:t>
-            </a:r>
-          </a:p>
-        </p:txBody>
-      </p:sp>
       <p:cxnSp>
         <p:nvCxnSpPr>
-          <p:cNvPr id="26" name="Connector 25"/>
+          <p:cNvPr id="36" name="Connector 35"/>
           <p:cNvCxnSpPr/>
           <p:nvPr/>
         </p:nvCxnSpPr>
         <p:spPr>
-          <a:xfrm>
-            <a:off x="108000" y="306000"/>
-            <a:ext cx="216000" cy="0"/>
+          <a:xfrm flipV="1">
+            <a:off x="152400" y="996950"/>
+            <a:ext cx="0" cy="1860550"/>
           </a:xfrm>
           <a:prstGeom prst="line">
             <a:avLst/>
           </a:prstGeom>
           <a:ln w="12700">
             <a:solidFill>
-              <a:srgbClr val="1F1F1F"/>
+              <a:srgbClr val="243343"/>
             </a:solidFill>
+            <a:prstDash val="dash"/>
           </a:ln>
         </p:spPr>
         <p:style>
@@ -4192,60 +4708,26 @@
           </a:fontRef>
         </p:style>
       </p:cxnSp>
-      <p:sp>
-        <p:nvSpPr>
-          <p:cNvPr id="27" name="TextBox 26"/>
-          <p:cNvSpPr txBox="1"/>
-          <p:nvPr/>
-        </p:nvSpPr>
-        <p:spPr>
-          <a:xfrm>
-            <a:off x="360000" y="198000"/>
-            <a:ext cx="1944000" cy="270000"/>
-          </a:xfrm>
-          <a:prstGeom prst="rect">
-            <a:avLst/>
-          </a:prstGeom>
-          <a:noFill/>
-        </p:spPr>
-        <p:txBody>
-          <a:bodyPr wrap="square" lIns="10800" rIns="10800" tIns="3600" bIns="3600">
-            <a:spAutoFit/>
-          </a:bodyPr>
-          <a:lstStyle/>
-          <a:p>
-            <a:pPr algn="l"/>
-            <a:r>
-              <a:rPr sz="1000" b="0">
-                <a:solidFill>
-                  <a:srgbClr val="1F1F1F"/>
-                </a:solidFill>
-                <a:latin typeface="Arial"/>
-              </a:rPr>
-              <a:t>validated in this dissertation</a:t>
-            </a:r>
-          </a:p>
-        </p:txBody>
-      </p:sp>
       <p:cxnSp>
         <p:nvCxnSpPr>
-          <p:cNvPr id="28" name="Connector 27"/>
+          <p:cNvPr id="37" name="Connector 36"/>
           <p:cNvCxnSpPr/>
           <p:nvPr/>
         </p:nvCxnSpPr>
         <p:spPr>
           <a:xfrm>
-            <a:off x="2376000" y="306000"/>
-            <a:ext cx="216000" cy="0"/>
+            <a:off x="152400" y="996950"/>
+            <a:ext cx="203200" cy="0"/>
           </a:xfrm>
           <a:prstGeom prst="line">
             <a:avLst/>
           </a:prstGeom>
           <a:ln w="12700">
             <a:solidFill>
-              <a:srgbClr val="1F1F1F"/>
+              <a:srgbClr val="243343"/>
             </a:solidFill>
             <a:prstDash val="dash"/>
+            <a:tailEnd type="triangle" w="sm" len="sm"/>
           </a:ln>
         </p:spPr>
         <p:style>
@@ -4265,14 +4747,14 @@
       </p:cxnSp>
       <p:sp>
         <p:nvSpPr>
-          <p:cNvPr id="29" name="TextBox 28"/>
+          <p:cNvPr id="38" name="TextBox 37"/>
           <p:cNvSpPr txBox="1"/>
           <p:nvPr/>
         </p:nvSpPr>
         <p:spPr>
           <a:xfrm>
-            <a:off x="2628000" y="198000"/>
-            <a:ext cx="936000" cy="270000"/>
+            <a:off x="1892300" y="2628900"/>
+            <a:ext cx="2159000" cy="190500"/>
           </a:xfrm>
           <a:prstGeom prst="rect">
             <a:avLst/>
@@ -4280,20 +4762,30 @@
           <a:noFill/>
         </p:spPr>
         <p:txBody>
-          <a:bodyPr wrap="square" lIns="10800" rIns="10800" tIns="3600" bIns="3600">
-            <a:spAutoFit/>
+          <a:bodyPr wrap="none" lIns="0" rIns="0" tIns="0" bIns="0">
+            <a:noAutofit/>
           </a:bodyPr>
           <a:lstStyle/>
           <a:p>
-            <a:pPr algn="l"/>
-            <a:r>
-              <a:rPr sz="1000" b="0">
+            <a:pPr algn="ctr">
+              <a:lnSpc>
+                <a:spcPts val="1188"/>
+              </a:lnSpc>
+              <a:spcBef>
+                <a:spcPts val="0"/>
+              </a:spcBef>
+              <a:spcAft>
+                <a:spcPts val="0"/>
+              </a:spcAft>
+            </a:pPr>
+            <a:r>
+              <a:rPr sz="1080" b="0" i="0">
                 <a:solidFill>
-                  <a:srgbClr val="1F1F1F"/>
+                  <a:srgbClr val="243343"/>
                 </a:solidFill>
                 <a:latin typeface="Arial"/>
               </a:rPr>
-              <a:t>future work</a:t>
+              <a:t>Biological insight (future)</a:t>
             </a:r>
           </a:p>
         </p:txBody>

</xml_diff>